<commit_message>
WaferEngine-staging: weekly deck slides 6-7 rework (model panel; transport-vs-CE decomposition)
</commit_message>
<xml_diff>
--- a/projects/WaferEngine-staging/meetings/2026-08-24.pptx
+++ b/projects/WaferEngine-staging/meetings/2026-08-24.pptx
@@ -649,7 +649,7 @@
           <a:lstStyle/>
           <a:p>
             <a:r>
-              <a:t>v4 wins every measured R&gt;=2 cell, so this page intentionally removes v3/v5. Model form: C_v4 = C_floor + (E-4)N*C_owner + W_fwd*C_router, W_fwd=(N-N/R)E. C_floor prices launch/control and role setup. C_owner prices the ordinary endpoint path per payload word: 96.00 task / 65.08 owner-DSD. C_router is the incremental multi-row forwarding tax: 1.06 / 1.29 cycles per forwarded word. The topology crop is derived from docs/diagrams/m3-multirow-v4-vs-v5.excalidraw; it shows the sequential GO epoch and router transit row.</a:t>
+              <a:t>Replaces the earlier v4-equation slide per Le's request: full model view, modest typography. The v4-topology figure remains in figures/fig_v4_model_topology.png if wanted back. Deeper provenance: PREREGISTRATION-multirow.md consolidated record; perf_model.py --selftest.</a:t>
             </a:r>
           </a:p>
         </p:txBody>
@@ -695,7 +695,7 @@
           <a:lstStyle/>
           <a:p>
             <a:r>
-              <a:t>Two measured router-only terms: distance adds t_hop=2.0 cycles per transit hop per direction, so the full-cycle increment is 2(D-1)t_hop; v4 multi-row forwarding adds 1.06/1.29 cycles per forwarded word. CE coefficients are much larger: emit loop 13.0, reload relay about 28.8, park receive 43.3, receive+validate+forward 75.4 cycles/word. The comparison is mechanism-level: t_hop has units cycles/hop and is not plotted beside cycles/word. Pipeline stages combine by the binding maximum, not an unconditional sum. The demo blocks compute at the round boundary, so live concurrent-CE interference remains unmeasured.</a:t>
+              <a:t>The remaining CE items on the tier's critical path are storage park receive (43.3, task) and emit (13.0, sync loop) — the projected ~4-5x next rung (labeled projection). Transport-side open items are congestion-class, not latency-class: link sharing with live decode and multi-lane aggregation are unmeasured (all runs isolated single-lane). Wire floor 1 word/cyc/link is spec, not measured; everything else on the chart is a device fit.</a:t>
             </a:r>
           </a:p>
         </p:txBody>
@@ -6136,7 +6136,7 @@
                 </a:solidFill>
                 <a:latin typeface="Arial"/>
               </a:rPr>
-              <a:t>MODEL · V4 GO-CHAIN, MEASURED WINNER FOR R &gt;= 2</a:t>
+              <a:t>MODEL · EQUATIONS AND FITTED COEFFICIENTS</a:t>
             </a:r>
           </a:p>
         </p:txBody>
@@ -6175,14 +6175,14 @@
                 </a:solidFill>
                 <a:latin typeface="Arial"/>
               </a:rPr>
-              <a:t>v4 cost = endpoint baseline + router-only forwarding</a:t>
+              <a:t>Three device-fit models, one coefficient table</a:t>
             </a:r>
           </a:p>
         </p:txBody>
       </p:sp>
       <p:pic>
         <p:nvPicPr>
-          <p:cNvPr id="4" name="figure" descr="fig_v4_model_topology.png"/>
+          <p:cNvPr id="4" name="figure" descr="fig_model_panel.png"/>
           <p:cNvPicPr>
             <a:picLocks noChangeAspect="1"/>
           </p:cNvPicPr>
@@ -6196,8 +6196,8 @@
         </p:blipFill>
         <p:spPr>
           <a:xfrm>
-            <a:off x="2981063" y="2484882"/>
-            <a:ext cx="12325873" cy="4944618"/>
+            <a:off x="4481931" y="2484882"/>
+            <a:ext cx="9324136" cy="4944618"/>
           </a:xfrm>
           <a:prstGeom prst="rect">
             <a:avLst/>
@@ -6238,7 +6238,7 @@
                 </a:solidFill>
                 <a:latin typeface="Arial"/>
               </a:rPr>
-              <a:t>Generic equation first, fitted coefficients second, topology at right. Setting: N=256, E&gt;=64; pairs are task | owner-side bulk-DSD. v4 epoch_sum excludes small inter-epoch GO gaps.</a:t>
+              <a:t>Internal-discussion reference: the three fitted equations (task | dsd pairs) and every coefficient with its meaning and fit provenance. All values are real CS-3 measurements; selftest reproduces 39 device anchors under 1%.</a:t>
             </a:r>
           </a:p>
         </p:txBody>
@@ -6295,7 +6295,7 @@
                 </a:solidFill>
                 <a:latin typeface="Arial"/>
               </a:rPr>
-              <a:t>MECHANISM · ROUTER TRANSIT VS CE PROCESSING</a:t>
+              <a:t>INSIGHT · TRANSPORT VS CE, AND THE KNOB FOR EACH</a:t>
             </a:r>
           </a:p>
         </p:txBody>
@@ -6309,7 +6309,7 @@
         <p:spPr>
           <a:xfrm>
             <a:off x="987552" y="1371600"/>
-            <a:ext cx="16312896" cy="674369"/>
+            <a:ext cx="16312896" cy="1348739"/>
           </a:xfrm>
           <a:prstGeom prst="rect">
             <a:avLst/>
@@ -6334,7 +6334,7 @@
                 </a:solidFill>
                 <a:latin typeface="Arial"/>
               </a:rPr>
-              <a:t>The fabric is not binding: CE per-word handling dominates</a:t>
+              <a:t>Pure transport is 1-2 cyc/word; CE send/recv is 13-75 — and each class has its own lever</a:t>
             </a:r>
           </a:p>
         </p:txBody>
@@ -6355,8 +6355,8 @@
         </p:blipFill>
         <p:spPr>
           <a:xfrm>
-            <a:off x="3865667" y="2484882"/>
-            <a:ext cx="10556665" cy="4944618"/>
+            <a:off x="5527548" y="3159251"/>
+            <a:ext cx="7232903" cy="3616451"/>
           </a:xfrm>
           <a:prstGeom prst="rect">
             <a:avLst/>
@@ -6371,8 +6371,8 @@
         </p:nvSpPr>
         <p:spPr>
           <a:xfrm>
-            <a:off x="987552" y="7703820"/>
-            <a:ext cx="16312896" cy="653796"/>
+            <a:off x="987552" y="7050023"/>
+            <a:ext cx="16312896" cy="1307592"/>
           </a:xfrm>
           <a:prstGeom prst="rect">
             <a:avLst/>
@@ -6397,7 +6397,7 @@
                 </a:solidFill>
                 <a:latin typeface="Arial"/>
               </a:rPr>
-              <a:t>Router-only means switch-to-switch transit with no RAMP, IQ/task, CE landing, or local copy/re-emit. It still consumes links and can backpressure; current measurements are isolated, single-lane runs.</a:t>
+              <a:t>Left: every measured per-word cost, colored by class — transport (router/wire) vs CE send/recv. Right: what moves each class. Transport depends on storage-PE placement, measured latency-free (2.0 cyc/hop, no per-word term). CE depends on the thread model (task -&gt; DSD, measured on the owner side) and on how work is allocated across CEs: v5 concentrates all forwarding on row-0's CE (tax 30.7-47.0) while v4 leaves inter-row movement to routers (tax 1.06-1.29) — the 25-35x gap is the allocation decision itself, measured.</a:t>
             </a:r>
           </a:p>
         </p:txBody>

</xml_diff>